<commit_message>
.\Python\Lesson 10 - HTTP and APIs"
</commit_message>
<xml_diff>
--- a/Python/Lesson 10 - HTTP and APIs/HTTP and APIs.pptx
+++ b/Python/Lesson 10 - HTTP and APIs/HTTP and APIs.pptx
@@ -667,6 +667,18 @@
           <a:p>
             <a:r>
               <a:rPr lang="en-US" dirty="0"/>
+              <a:t>How do two applications talk to each other effectively </a:t>
+            </a:r>
+          </a:p>
+          <a:p>
+            <a:endParaRPr lang="en-US" dirty="0"/>
+          </a:p>
+          <a:p>
+            <a:endParaRPr lang="en-US" dirty="0"/>
+          </a:p>
+          <a:p>
+            <a:r>
+              <a:rPr lang="en-US" dirty="0"/>
               <a:t>GET /test HTTP/1.1</a:t>
             </a:r>
           </a:p>
@@ -941,33 +953,6 @@
           <a:bodyPr/>
           <a:lstStyle/>
           <a:p>
-            <a:r>
-              <a:rPr lang="en-US" dirty="0"/>
-              <a:t>GET /test HTTP/1.1</a:t>
-            </a:r>
-          </a:p>
-          <a:p>
-            <a:r>
-              <a:rPr lang="en-US" dirty="0"/>
-              <a:t>Host: example.com</a:t>
-            </a:r>
-          </a:p>
-          <a:p>
-            <a:r>
-              <a:rPr lang="en-US" dirty="0"/>
-              <a:t>Accept: */*</a:t>
-            </a:r>
-          </a:p>
-          <a:p>
-            <a:endParaRPr lang="en-US" dirty="0"/>
-          </a:p>
-          <a:p>
-            <a:r>
-              <a:rPr lang="en-US" dirty="0"/>
-              <a:t>{"param"="hello"}</a:t>
-            </a:r>
-          </a:p>
-          <a:p>
             <a:endParaRPr lang="en-US" dirty="0"/>
           </a:p>
           <a:p>
@@ -1063,75 +1048,365 @@
           <a:p>
             <a:r>
               <a:rPr lang="en-US" dirty="0"/>
-              <a:t>Pros:</a:t>
-            </a:r>
-          </a:p>
-          <a:p>
-            <a:pPr marL="171450" indent="-171450">
-              <a:buFontTx/>
-              <a:buChar char="-"/>
-            </a:pPr>
-            <a:r>
+              <a:t>GitHub example:</a:t>
+            </a:r>
+            <a:br>
               <a:rPr lang="en-US" dirty="0"/>
-              <a:t>Simple</a:t>
-            </a:r>
-          </a:p>
-          <a:p>
-            <a:pPr marL="171450" indent="-171450">
-              <a:buFontTx/>
-              <a:buChar char="-"/>
-            </a:pPr>
-            <a:r>
+            </a:br>
+            <a:br>
               <a:rPr lang="en-US" dirty="0"/>
-              <a:t>Stateless</a:t>
-            </a:r>
-          </a:p>
-          <a:p>
-            <a:pPr marL="171450" indent="-171450">
-              <a:buFontTx/>
-              <a:buChar char="-"/>
-            </a:pPr>
+            </a:br>
+            <a:r>
+              <a:rPr lang="en-US" b="1" dirty="0"/>
+              <a:t>Endpoint: </a:t>
+            </a:r>
+          </a:p>
+          <a:p>
+            <a:endParaRPr lang="en-US" dirty="0"/>
+          </a:p>
+          <a:p>
             <a:r>
               <a:rPr lang="en-US" dirty="0"/>
-              <a:t>User-specific</a:t>
-            </a:r>
-          </a:p>
-          <a:p>
-            <a:pPr marL="0" indent="0">
-              <a:buFontTx/>
-              <a:buNone/>
-            </a:pPr>
+              <a:t>Repos/{owner}/{repo}/compare/{basehead}</a:t>
+            </a:r>
+          </a:p>
+          <a:p>
             <a:endParaRPr lang="en-US" dirty="0"/>
           </a:p>
           <a:p>
-            <a:pPr marL="0" indent="0">
-              <a:buFontTx/>
-              <a:buNone/>
-            </a:pPr>
-            <a:r>
+            <a:r>
+              <a:rPr lang="en-US" b="1" dirty="0"/>
+              <a:t>Required Parameters:</a:t>
+            </a:r>
+            <a:br>
               <a:rPr lang="en-US" dirty="0"/>
-              <a:t>Cons;</a:t>
-            </a:r>
-          </a:p>
-          <a:p>
-            <a:pPr marL="171450" indent="-171450">
-              <a:buFontTx/>
-              <a:buChar char="-"/>
-            </a:pPr>
-            <a:r>
+            </a:br>
+            <a:endParaRPr lang="en-US" dirty="0"/>
+          </a:p>
+          <a:p>
+            <a:r>
+              <a:rPr lang="en-US" sz="1200" b="0" i="0" kern="1200" dirty="0">
+                <a:solidFill>
+                  <a:schemeClr val="tx1"/>
+                </a:solidFill>
+                <a:effectLst/>
+                <a:latin typeface="+mn-lt"/>
+                <a:ea typeface="+mn-ea"/>
+                <a:cs typeface="+mn-cs"/>
+              </a:rPr>
+              <a:t>Path parameters</a:t>
+            </a:r>
+          </a:p>
+          <a:p>
+            <a:pPr fontAlgn="t"/>
+            <a:endParaRPr lang="en-US" sz="1200" b="1" i="0" kern="1200" dirty="0">
+              <a:solidFill>
+                <a:schemeClr val="tx1"/>
+              </a:solidFill>
+              <a:effectLst/>
+              <a:latin typeface="+mn-lt"/>
+              <a:ea typeface="+mn-ea"/>
+              <a:cs typeface="+mn-cs"/>
+            </a:endParaRPr>
+          </a:p>
+          <a:p>
+            <a:pPr fontAlgn="t"/>
+            <a:r>
+              <a:rPr lang="en-US" sz="1200" b="1" i="0" kern="1200" dirty="0">
+                <a:solidFill>
+                  <a:schemeClr val="tx1"/>
+                </a:solidFill>
+                <a:effectLst/>
+                <a:latin typeface="+mn-lt"/>
+                <a:ea typeface="+mn-ea"/>
+                <a:cs typeface="+mn-cs"/>
+              </a:rPr>
+              <a:t>owner</a:t>
+            </a:r>
+            <a:r>
+              <a:rPr lang="en-US" sz="1200" b="0" i="0" kern="1200" dirty="0">
+                <a:solidFill>
+                  <a:schemeClr val="tx1"/>
+                </a:solidFill>
+                <a:effectLst/>
+                <a:latin typeface="+mn-lt"/>
+                <a:ea typeface="+mn-ea"/>
+                <a:cs typeface="+mn-cs"/>
+              </a:rPr>
+              <a:t> string Required</a:t>
+            </a:r>
+          </a:p>
+          <a:p>
+            <a:pPr fontAlgn="t"/>
+            <a:r>
+              <a:rPr lang="en-US" sz="1200" b="0" i="0" kern="1200" dirty="0">
+                <a:solidFill>
+                  <a:schemeClr val="tx1"/>
+                </a:solidFill>
+                <a:effectLst/>
+                <a:latin typeface="+mn-lt"/>
+                <a:ea typeface="+mn-ea"/>
+                <a:cs typeface="+mn-cs"/>
+              </a:rPr>
+              <a:t>The account owner of the repository. The name is not case sensitive.</a:t>
+            </a:r>
+          </a:p>
+          <a:p>
+            <a:pPr fontAlgn="t"/>
+            <a:endParaRPr lang="en-US" sz="1200" b="1" i="0" kern="1200" dirty="0">
+              <a:solidFill>
+                <a:schemeClr val="tx1"/>
+              </a:solidFill>
+              <a:effectLst/>
+              <a:latin typeface="+mn-lt"/>
+              <a:ea typeface="+mn-ea"/>
+              <a:cs typeface="+mn-cs"/>
+            </a:endParaRPr>
+          </a:p>
+          <a:p>
+            <a:pPr fontAlgn="t"/>
+            <a:r>
+              <a:rPr lang="en-US" sz="1200" b="1" i="0" kern="1200" dirty="0">
+                <a:solidFill>
+                  <a:schemeClr val="tx1"/>
+                </a:solidFill>
+                <a:effectLst/>
+                <a:latin typeface="+mn-lt"/>
+                <a:ea typeface="+mn-ea"/>
+                <a:cs typeface="+mn-cs"/>
+              </a:rPr>
+              <a:t>repo</a:t>
+            </a:r>
+            <a:r>
+              <a:rPr lang="en-US" sz="1200" b="0" i="0" kern="1200" dirty="0">
+                <a:solidFill>
+                  <a:schemeClr val="tx1"/>
+                </a:solidFill>
+                <a:effectLst/>
+                <a:latin typeface="+mn-lt"/>
+                <a:ea typeface="+mn-ea"/>
+                <a:cs typeface="+mn-cs"/>
+              </a:rPr>
+              <a:t> string Required</a:t>
+            </a:r>
+          </a:p>
+          <a:p>
+            <a:pPr fontAlgn="t"/>
+            <a:r>
+              <a:rPr lang="en-US" sz="1200" b="0" i="0" kern="1200" dirty="0">
+                <a:solidFill>
+                  <a:schemeClr val="tx1"/>
+                </a:solidFill>
+                <a:effectLst/>
+                <a:latin typeface="+mn-lt"/>
+                <a:ea typeface="+mn-ea"/>
+                <a:cs typeface="+mn-cs"/>
+              </a:rPr>
+              <a:t>The name of the repository without the .git extension. The name is not case sensitive.</a:t>
+            </a:r>
+          </a:p>
+          <a:p>
+            <a:pPr fontAlgn="t"/>
+            <a:endParaRPr lang="en-US" sz="1200" b="1" i="0" kern="1200" dirty="0">
+              <a:solidFill>
+                <a:schemeClr val="tx1"/>
+              </a:solidFill>
+              <a:effectLst/>
+              <a:latin typeface="+mn-lt"/>
+              <a:ea typeface="+mn-ea"/>
+              <a:cs typeface="+mn-cs"/>
+            </a:endParaRPr>
+          </a:p>
+          <a:p>
+            <a:pPr fontAlgn="t"/>
+            <a:r>
+              <a:rPr lang="en-US" sz="1200" b="1" i="0" kern="1200" dirty="0">
+                <a:solidFill>
+                  <a:schemeClr val="tx1"/>
+                </a:solidFill>
+                <a:effectLst/>
+                <a:latin typeface="+mn-lt"/>
+                <a:ea typeface="+mn-ea"/>
+                <a:cs typeface="+mn-cs"/>
+              </a:rPr>
+              <a:t>basehead</a:t>
+            </a:r>
+            <a:r>
+              <a:rPr lang="en-US" sz="1200" b="0" i="0" kern="1200" dirty="0">
+                <a:solidFill>
+                  <a:schemeClr val="tx1"/>
+                </a:solidFill>
+                <a:effectLst/>
+                <a:latin typeface="+mn-lt"/>
+                <a:ea typeface="+mn-ea"/>
+                <a:cs typeface="+mn-cs"/>
+              </a:rPr>
+              <a:t> string Required</a:t>
+            </a:r>
+          </a:p>
+          <a:p>
+            <a:pPr fontAlgn="t"/>
+            <a:r>
+              <a:rPr lang="en-US" sz="1200" b="0" i="0" kern="1200" dirty="0">
+                <a:solidFill>
+                  <a:schemeClr val="tx1"/>
+                </a:solidFill>
+                <a:effectLst/>
+                <a:latin typeface="+mn-lt"/>
+                <a:ea typeface="+mn-ea"/>
+                <a:cs typeface="+mn-cs"/>
+              </a:rPr>
+              <a:t>The base branch and head branch to compare. This parameter expects the format BASE...HEAD. Both must be branch names in repo. To compare with a branch that exists in a different repository in the same network as repo, the basehead parameter expects the format USERNAME:BASE...USERNAME:HEAD.</a:t>
+            </a:r>
+          </a:p>
+          <a:p>
+            <a:endParaRPr lang="en-US" dirty="0"/>
+          </a:p>
+          <a:p>
+            <a:endParaRPr lang="en-US" dirty="0"/>
+          </a:p>
+          <a:p>
+            <a:endParaRPr lang="en-US" dirty="0"/>
+          </a:p>
+          <a:p>
+            <a:r>
+              <a:rPr lang="en-US" b="1" dirty="0"/>
+              <a:t>Optional Parameters:</a:t>
+            </a:r>
+          </a:p>
+          <a:p>
+            <a:endParaRPr lang="en-US" b="1" dirty="0"/>
+          </a:p>
+          <a:p>
+            <a:r>
+              <a:rPr lang="en-US" b="0" dirty="0"/>
+              <a:t>Page</a:t>
+            </a:r>
+          </a:p>
+          <a:p>
+            <a:r>
+              <a:rPr lang="en-US" b="0" dirty="0"/>
+              <a:t>Per page</a:t>
+            </a:r>
+            <a:endParaRPr lang="en-US" dirty="0"/>
+          </a:p>
+          <a:p>
+            <a:endParaRPr lang="en-US" dirty="0"/>
+          </a:p>
+          <a:p>
+            <a:endParaRPr lang="en-US" dirty="0"/>
+          </a:p>
+          <a:p>
+            <a:r>
+              <a:rPr lang="en-US" b="1" dirty="0"/>
+              <a:t>Multiple Responses:</a:t>
+            </a:r>
+            <a:br>
               <a:rPr lang="en-US" dirty="0"/>
-              <a:t>Sending password repeatedly</a:t>
-            </a:r>
-          </a:p>
-          <a:p>
-            <a:pPr marL="171450" indent="-171450">
-              <a:buFontTx/>
-              <a:buChar char="-"/>
-            </a:pPr>
-            <a:r>
+            </a:br>
+            <a:endParaRPr lang="en-US" dirty="0"/>
+          </a:p>
+          <a:p>
+            <a:r>
+              <a:rPr lang="en-US" sz="1200" b="0" i="0" kern="1200" dirty="0">
+                <a:solidFill>
+                  <a:schemeClr val="tx1"/>
+                </a:solidFill>
+                <a:effectLst/>
+                <a:latin typeface="+mn-lt"/>
+                <a:ea typeface="+mn-ea"/>
+                <a:cs typeface="+mn-cs"/>
+              </a:rPr>
+              <a:t>To process a response with a large number of commits, use a query parameter (</a:t>
+            </a:r>
+            <a:r>
+              <a:rPr lang="en-US" sz="1200" b="0" i="0" kern="1200" dirty="0" err="1">
+                <a:solidFill>
+                  <a:schemeClr val="tx1"/>
+                </a:solidFill>
+                <a:effectLst/>
+                <a:latin typeface="+mn-lt"/>
+                <a:ea typeface="+mn-ea"/>
+                <a:cs typeface="+mn-cs"/>
+              </a:rPr>
+              <a:t>per_page</a:t>
+            </a:r>
+            <a:r>
+              <a:rPr lang="en-US" sz="1200" b="0" i="0" kern="1200" dirty="0">
+                <a:solidFill>
+                  <a:schemeClr val="tx1"/>
+                </a:solidFill>
+                <a:effectLst/>
+                <a:latin typeface="+mn-lt"/>
+                <a:ea typeface="+mn-ea"/>
+                <a:cs typeface="+mn-cs"/>
+              </a:rPr>
+              <a:t> or page) to paginate the results. </a:t>
+            </a:r>
+          </a:p>
+          <a:p>
+            <a:endParaRPr lang="en-US" sz="1200" b="0" i="0" kern="1200" dirty="0">
+              <a:solidFill>
+                <a:schemeClr val="tx1"/>
+              </a:solidFill>
+              <a:effectLst/>
+              <a:latin typeface="+mn-lt"/>
+              <a:ea typeface="+mn-ea"/>
+              <a:cs typeface="+mn-cs"/>
+            </a:endParaRPr>
+          </a:p>
+          <a:p>
+            <a:r>
+              <a:rPr lang="en-US" sz="1200" b="0" i="0" kern="1200" dirty="0">
+                <a:solidFill>
+                  <a:schemeClr val="tx1"/>
+                </a:solidFill>
+                <a:effectLst/>
+                <a:latin typeface="+mn-lt"/>
+                <a:ea typeface="+mn-ea"/>
+                <a:cs typeface="+mn-cs"/>
+              </a:rPr>
+              <a:t>When using pagination:</a:t>
+            </a:r>
+          </a:p>
+          <a:p>
+            <a:pPr lvl="0"/>
+            <a:r>
+              <a:rPr lang="en-US" sz="1200" b="0" i="0" kern="1200" dirty="0">
+                <a:solidFill>
+                  <a:schemeClr val="tx1"/>
+                </a:solidFill>
+                <a:effectLst/>
+                <a:latin typeface="+mn-lt"/>
+                <a:ea typeface="+mn-ea"/>
+                <a:cs typeface="+mn-cs"/>
+              </a:rPr>
+              <a:t>The list of changed files is only shown on the first page of results, and it includes up to 300 changed files for the entire comparison.</a:t>
+            </a:r>
+          </a:p>
+          <a:p>
+            <a:pPr lvl="0"/>
+            <a:r>
+              <a:rPr lang="en-US" sz="1200" b="0" i="0" kern="1200" dirty="0">
+                <a:solidFill>
+                  <a:schemeClr val="tx1"/>
+                </a:solidFill>
+                <a:effectLst/>
+                <a:latin typeface="+mn-lt"/>
+                <a:ea typeface="+mn-ea"/>
+                <a:cs typeface="+mn-cs"/>
+              </a:rPr>
+              <a:t>The results are returned in chronological order, but the last commit in the returned list may not be the most recent one in the entire set if there are more pages of results.</a:t>
+            </a:r>
+          </a:p>
+          <a:p>
+            <a:br>
               <a:rPr lang="en-US" dirty="0"/>
-              <a:t>Cannot auth 3rd parties</a:t>
-            </a:r>
+            </a:br>
+            <a:br>
+              <a:rPr lang="en-US" dirty="0"/>
+            </a:br>
+            <a:endParaRPr lang="en-US" dirty="0"/>
           </a:p>
         </p:txBody>
       </p:sp>
@@ -1152,7 +1427,7 @@
           <a:p>
             <a:fld id="{BE457D5F-ED05-449E-97D0-205DAB987247}" type="slidenum">
               <a:rPr lang="en-US" smtClean="0"/>
-              <a:t>21</a:t>
+              <a:t>19</a:t>
             </a:fld>
             <a:endParaRPr lang="en-US"/>
           </a:p>
@@ -1161,7 +1436,7 @@
     </p:spTree>
     <p:extLst>
       <p:ext uri="{BB962C8B-B14F-4D97-AF65-F5344CB8AC3E}">
-        <p14:creationId xmlns:p14="http://schemas.microsoft.com/office/powerpoint/2010/main" val="1265215026"/>
+        <p14:creationId xmlns:p14="http://schemas.microsoft.com/office/powerpoint/2010/main" val="2607826317"/>
       </p:ext>
     </p:extLst>
   </p:cSld>
@@ -1247,7 +1522,7 @@
             </a:pPr>
             <a:r>
               <a:rPr lang="en-US" dirty="0"/>
-              <a:t>Can auth 3rd parties</a:t>
+              <a:t>User-specific</a:t>
             </a:r>
           </a:p>
           <a:p>
@@ -1274,7 +1549,7 @@
             </a:pPr>
             <a:r>
               <a:rPr lang="en-US" dirty="0"/>
-              <a:t>Hard to rotate keys</a:t>
+              <a:t>Sending password repeatedly</a:t>
             </a:r>
           </a:p>
           <a:p>
@@ -1284,11 +1559,47 @@
             </a:pPr>
             <a:r>
               <a:rPr lang="en-US" dirty="0"/>
-              <a:t>Generally not user-specific</a:t>
-            </a:r>
-          </a:p>
-          <a:p>
+              <a:t>Cannot auth 3rd parties</a:t>
+            </a:r>
+          </a:p>
+          <a:p>
+            <a:pPr marL="171450" indent="-171450">
+              <a:buFontTx/>
+              <a:buChar char="-"/>
+            </a:pPr>
             <a:endParaRPr lang="en-US" dirty="0"/>
+          </a:p>
+          <a:p>
+            <a:pPr marL="171450" indent="-171450">
+              <a:buFontTx/>
+              <a:buChar char="-"/>
+            </a:pPr>
+            <a:endParaRPr lang="en-US" dirty="0"/>
+          </a:p>
+          <a:p>
+            <a:pPr marL="171450" indent="-171450">
+              <a:buFontTx/>
+              <a:buChar char="-"/>
+            </a:pPr>
+            <a:endParaRPr lang="en-US" dirty="0"/>
+          </a:p>
+          <a:p>
+            <a:pPr marL="0" indent="0">
+              <a:buFontTx/>
+              <a:buNone/>
+            </a:pPr>
+            <a:r>
+              <a:rPr lang="en-US" dirty="0"/>
+              <a:t>Sent to the system ‘</a:t>
+            </a:r>
+            <a:r>
+              <a:rPr lang="en-US" dirty="0" err="1"/>
+              <a:t>username:password</a:t>
+            </a:r>
+            <a:r>
+              <a:rPr lang="en-US" dirty="0"/>
+              <a:t> (basic 64 encoded)’</a:t>
+            </a:r>
           </a:p>
         </p:txBody>
       </p:sp>
@@ -1309,7 +1620,7 @@
           <a:p>
             <a:fld id="{BE457D5F-ED05-449E-97D0-205DAB987247}" type="slidenum">
               <a:rPr lang="en-US" smtClean="0"/>
-              <a:t>22</a:t>
+              <a:t>21</a:t>
             </a:fld>
             <a:endParaRPr lang="en-US"/>
           </a:p>
@@ -1318,7 +1629,7 @@
     </p:spTree>
     <p:extLst>
       <p:ext uri="{BB962C8B-B14F-4D97-AF65-F5344CB8AC3E}">
-        <p14:creationId xmlns:p14="http://schemas.microsoft.com/office/powerpoint/2010/main" val="1253076170"/>
+        <p14:creationId xmlns:p14="http://schemas.microsoft.com/office/powerpoint/2010/main" val="1265215026"/>
       </p:ext>
     </p:extLst>
   </p:cSld>
@@ -1394,24 +1705,7 @@
             </a:pPr>
             <a:r>
               <a:rPr lang="en-US" dirty="0"/>
-              <a:t>User-specific</a:t>
-            </a:r>
-          </a:p>
-          <a:p>
-            <a:pPr marL="0" indent="0">
-              <a:buFontTx/>
-              <a:buNone/>
-            </a:pPr>
-            <a:endParaRPr lang="en-US" dirty="0"/>
-          </a:p>
-          <a:p>
-            <a:pPr marL="0" indent="0">
-              <a:buFontTx/>
-              <a:buNone/>
-            </a:pPr>
-            <a:r>
-              <a:rPr lang="en-US" dirty="0"/>
-              <a:t>Cons:</a:t>
+              <a:t>Stateless</a:t>
             </a:r>
           </a:p>
           <a:p>
@@ -1421,7 +1715,24 @@
             </a:pPr>
             <a:r>
               <a:rPr lang="en-US" dirty="0"/>
-              <a:t>Stateful</a:t>
+              <a:t>Can auth 3rd parties</a:t>
+            </a:r>
+          </a:p>
+          <a:p>
+            <a:pPr marL="0" indent="0">
+              <a:buFontTx/>
+              <a:buNone/>
+            </a:pPr>
+            <a:endParaRPr lang="en-US" dirty="0"/>
+          </a:p>
+          <a:p>
+            <a:pPr marL="0" indent="0">
+              <a:buFontTx/>
+              <a:buNone/>
+            </a:pPr>
+            <a:r>
+              <a:rPr lang="en-US" dirty="0"/>
+              <a:t>Cons;</a:t>
             </a:r>
           </a:p>
           <a:p>
@@ -1431,7 +1742,17 @@
             </a:pPr>
             <a:r>
               <a:rPr lang="en-US" dirty="0"/>
-              <a:t>Cannot auth 3rd parties</a:t>
+              <a:t>Hard to rotate keys</a:t>
+            </a:r>
+          </a:p>
+          <a:p>
+            <a:pPr marL="171450" indent="-171450">
+              <a:buFontTx/>
+              <a:buChar char="-"/>
+            </a:pPr>
+            <a:r>
+              <a:rPr lang="en-US" dirty="0"/>
+              <a:t>Generally not user-specific</a:t>
             </a:r>
           </a:p>
           <a:p>
@@ -1456,7 +1777,7 @@
           <a:p>
             <a:fld id="{BE457D5F-ED05-449E-97D0-205DAB987247}" type="slidenum">
               <a:rPr lang="en-US" smtClean="0"/>
-              <a:t>23</a:t>
+              <a:t>22</a:t>
             </a:fld>
             <a:endParaRPr lang="en-US"/>
           </a:p>
@@ -1465,7 +1786,7 @@
     </p:spTree>
     <p:extLst>
       <p:ext uri="{BB962C8B-B14F-4D97-AF65-F5344CB8AC3E}">
-        <p14:creationId xmlns:p14="http://schemas.microsoft.com/office/powerpoint/2010/main" val="3830640556"/>
+        <p14:creationId xmlns:p14="http://schemas.microsoft.com/office/powerpoint/2010/main" val="1253076170"/>
       </p:ext>
     </p:extLst>
   </p:cSld>
@@ -1531,6 +1852,153 @@
             </a:pPr>
             <a:r>
               <a:rPr lang="en-US" dirty="0"/>
+              <a:t>Simple</a:t>
+            </a:r>
+          </a:p>
+          <a:p>
+            <a:pPr marL="171450" indent="-171450">
+              <a:buFontTx/>
+              <a:buChar char="-"/>
+            </a:pPr>
+            <a:r>
+              <a:rPr lang="en-US" dirty="0"/>
+              <a:t>User-specific</a:t>
+            </a:r>
+          </a:p>
+          <a:p>
+            <a:pPr marL="0" indent="0">
+              <a:buFontTx/>
+              <a:buNone/>
+            </a:pPr>
+            <a:endParaRPr lang="en-US" dirty="0"/>
+          </a:p>
+          <a:p>
+            <a:pPr marL="0" indent="0">
+              <a:buFontTx/>
+              <a:buNone/>
+            </a:pPr>
+            <a:r>
+              <a:rPr lang="en-US" dirty="0"/>
+              <a:t>Cons:</a:t>
+            </a:r>
+          </a:p>
+          <a:p>
+            <a:pPr marL="171450" indent="-171450">
+              <a:buFontTx/>
+              <a:buChar char="-"/>
+            </a:pPr>
+            <a:r>
+              <a:rPr lang="en-US" dirty="0"/>
+              <a:t>Stateful</a:t>
+            </a:r>
+          </a:p>
+          <a:p>
+            <a:pPr marL="171450" indent="-171450">
+              <a:buFontTx/>
+              <a:buChar char="-"/>
+            </a:pPr>
+            <a:r>
+              <a:rPr lang="en-US" dirty="0"/>
+              <a:t>Cannot auth 3rd parties</a:t>
+            </a:r>
+          </a:p>
+          <a:p>
+            <a:endParaRPr lang="en-US" dirty="0"/>
+          </a:p>
+        </p:txBody>
+      </p:sp>
+      <p:sp>
+        <p:nvSpPr>
+          <p:cNvPr id="4" name="Slide Number Placeholder 3"/>
+          <p:cNvSpPr>
+            <a:spLocks noGrp="1"/>
+          </p:cNvSpPr>
+          <p:nvPr>
+            <p:ph type="sldNum" sz="quarter" idx="5"/>
+          </p:nvPr>
+        </p:nvSpPr>
+        <p:spPr/>
+        <p:txBody>
+          <a:bodyPr/>
+          <a:lstStyle/>
+          <a:p>
+            <a:fld id="{BE457D5F-ED05-449E-97D0-205DAB987247}" type="slidenum">
+              <a:rPr lang="en-US" smtClean="0"/>
+              <a:t>23</a:t>
+            </a:fld>
+            <a:endParaRPr lang="en-US"/>
+          </a:p>
+        </p:txBody>
+      </p:sp>
+    </p:spTree>
+    <p:extLst>
+      <p:ext uri="{BB962C8B-B14F-4D97-AF65-F5344CB8AC3E}">
+        <p14:creationId xmlns:p14="http://schemas.microsoft.com/office/powerpoint/2010/main" val="3830640556"/>
+      </p:ext>
+    </p:extLst>
+  </p:cSld>
+  <p:clrMapOvr>
+    <a:masterClrMapping/>
+  </p:clrMapOvr>
+</p:notes>
+</file>
+
+<file path=ppt/notesSlides/notesSlide17.xml><?xml version="1.0" encoding="utf-8"?>
+<p:notes xmlns:a="http://schemas.openxmlformats.org/drawingml/2006/main" xmlns:r="http://schemas.openxmlformats.org/officeDocument/2006/relationships" xmlns:p="http://schemas.openxmlformats.org/presentationml/2006/main">
+  <p:cSld>
+    <p:spTree>
+      <p:nvGrpSpPr>
+        <p:cNvPr id="1" name=""/>
+        <p:cNvGrpSpPr/>
+        <p:nvPr/>
+      </p:nvGrpSpPr>
+      <p:grpSpPr>
+        <a:xfrm>
+          <a:off x="0" y="0"/>
+          <a:ext cx="0" cy="0"/>
+          <a:chOff x="0" y="0"/>
+          <a:chExt cx="0" cy="0"/>
+        </a:xfrm>
+      </p:grpSpPr>
+      <p:sp>
+        <p:nvSpPr>
+          <p:cNvPr id="2" name="Slide Image Placeholder 1"/>
+          <p:cNvSpPr>
+            <a:spLocks noGrp="1" noRot="1" noChangeAspect="1"/>
+          </p:cNvSpPr>
+          <p:nvPr>
+            <p:ph type="sldImg"/>
+          </p:nvPr>
+        </p:nvSpPr>
+        <p:spPr/>
+      </p:sp>
+      <p:sp>
+        <p:nvSpPr>
+          <p:cNvPr id="3" name="Notes Placeholder 2"/>
+          <p:cNvSpPr>
+            <a:spLocks noGrp="1"/>
+          </p:cNvSpPr>
+          <p:nvPr>
+            <p:ph type="body" idx="1"/>
+          </p:nvPr>
+        </p:nvSpPr>
+        <p:spPr/>
+        <p:txBody>
+          <a:bodyPr/>
+          <a:lstStyle/>
+          <a:p>
+            <a:r>
+              <a:rPr lang="en-US" dirty="0"/>
+              <a:t>Pros:</a:t>
+            </a:r>
+          </a:p>
+          <a:p>
+            <a:pPr marL="171450" indent="-171450">
+              <a:buFontTx/>
+              <a:buChar char="-"/>
+            </a:pPr>
+            <a:r>
+              <a:rPr lang="en-US" dirty="0"/>
               <a:t>Limited scope / time</a:t>
             </a:r>
           </a:p>
@@ -1631,7 +2099,7 @@
 </p:notes>
 </file>
 
-<file path=ppt/notesSlides/notesSlide17.xml><?xml version="1.0" encoding="utf-8"?>
+<file path=ppt/notesSlides/notesSlide18.xml><?xml version="1.0" encoding="utf-8"?>
 <p:notes xmlns:a="http://schemas.openxmlformats.org/drawingml/2006/main" xmlns:r="http://schemas.openxmlformats.org/officeDocument/2006/relationships" xmlns:p="http://schemas.openxmlformats.org/presentationml/2006/main">
   <p:cSld>
     <p:spTree>
@@ -2197,6 +2665,42 @@
               <a:t>https://www.rfc-editor.org/rfc/rfc1945#section-5</a:t>
             </a:r>
           </a:p>
+          <a:p>
+            <a:endParaRPr lang="en-US" dirty="0"/>
+          </a:p>
+          <a:p>
+            <a:r>
+              <a:rPr lang="en-US" dirty="0"/>
+              <a:t>200 everything is good to go </a:t>
+            </a:r>
+          </a:p>
+          <a:p>
+            <a:endParaRPr lang="en-US" dirty="0"/>
+          </a:p>
+          <a:p>
+            <a:r>
+              <a:rPr lang="en-US" dirty="0"/>
+              <a:t>300 go away, this isn’t here</a:t>
+            </a:r>
+          </a:p>
+          <a:p>
+            <a:endParaRPr lang="en-US" dirty="0"/>
+          </a:p>
+          <a:p>
+            <a:r>
+              <a:rPr lang="en-US" dirty="0"/>
+              <a:t>400 you probably made an error</a:t>
+            </a:r>
+          </a:p>
+          <a:p>
+            <a:endParaRPr lang="en-US" dirty="0"/>
+          </a:p>
+          <a:p>
+            <a:r>
+              <a:rPr lang="en-US" dirty="0"/>
+              <a:t>500 the server messed up </a:t>
+            </a:r>
+          </a:p>
         </p:txBody>
       </p:sp>
       <p:sp>
@@ -2284,6 +2788,21 @@
               <a:t>Hit an HTTP that returns HTML and one that returns a JSON response</a:t>
             </a:r>
           </a:p>
+          <a:p>
+            <a:endParaRPr lang="en-US" dirty="0"/>
+          </a:p>
+          <a:p>
+            <a:endParaRPr lang="en-US" dirty="0"/>
+          </a:p>
+          <a:p>
+            <a:endParaRPr lang="en-US" dirty="0"/>
+          </a:p>
+          <a:p>
+            <a:r>
+              <a:rPr lang="en-US" dirty="0"/>
+              <a:t>“You are just sending and receiving text” Maj Shafer</a:t>
+            </a:r>
+          </a:p>
         </p:txBody>
       </p:sp>
       <p:sp>
@@ -2369,6 +2888,27 @@
             <a:r>
               <a:rPr lang="en-US" dirty="0"/>
               <a:t>https://base64.dev/articles/what-is-base64</a:t>
+            </a:r>
+          </a:p>
+          <a:p>
+            <a:endParaRPr lang="en-US" dirty="0"/>
+          </a:p>
+          <a:p>
+            <a:endParaRPr lang="en-US" dirty="0"/>
+          </a:p>
+          <a:p>
+            <a:r>
+              <a:rPr lang="en-US" dirty="0"/>
+              <a:t>What you will see online.</a:t>
+            </a:r>
+          </a:p>
+          <a:p>
+            <a:endParaRPr lang="en-US" dirty="0"/>
+          </a:p>
+          <a:p>
+            <a:r>
+              <a:rPr lang="en-US" dirty="0"/>
+              <a:t>Convert everything to bites</a:t>
             </a:r>
           </a:p>
         </p:txBody>
@@ -28994,7 +29534,7 @@
             </a:r>
             <a:r>
               <a:rPr lang="en-US" dirty="0">
-                <a:hlinkClick r:id="rId2"/>
+                <a:hlinkClick r:id="rId3"/>
               </a:rPr>
               <a:t>https://api.github.com/repos/{owner}/{repo}/commits</a:t>
             </a:r>

</xml_diff>